<commit_message>
Update Day 1 slides (revised content)
</commit_message>
<xml_diff>
--- a/day1/Day1_MiniZinc_Slides.pptx
+++ b/day1/Day1_MiniZinc_Slides.pptx
@@ -24592,7 +24592,7 @@
         </p:nvSpPr>
         <p:spPr>
           <a:xfrm>
-            <a:off x="640080" y="2743200"/>
+            <a:off x="744255" y="2812650"/>
             <a:ext cx="1188720" cy="1097280"/>
           </a:xfrm>
           <a:prstGeom prst="rect">
@@ -24624,7 +24624,7 @@
         </p:nvSpPr>
         <p:spPr>
           <a:xfrm>
-            <a:off x="640080" y="2743200"/>
+            <a:off x="744255" y="2812650"/>
             <a:ext cx="1188720" cy="1097280"/>
           </a:xfrm>
           <a:prstGeom prst="rect">
@@ -24663,8 +24663,8 @@
         </p:nvSpPr>
         <p:spPr>
           <a:xfrm>
-            <a:off x="1920240" y="2651760"/>
-            <a:ext cx="914400" cy="822960"/>
+            <a:off x="1920240" y="2628610"/>
+            <a:ext cx="914400" cy="658368"/>
           </a:xfrm>
           <a:prstGeom prst="rect">
             <a:avLst/>
@@ -24695,7 +24695,7 @@
         </p:nvSpPr>
         <p:spPr>
           <a:xfrm>
-            <a:off x="1920240" y="2651760"/>
+            <a:off x="1920240" y="2524436"/>
             <a:ext cx="914400" cy="822960"/>
           </a:xfrm>
           <a:prstGeom prst="rect">
@@ -24734,8 +24734,8 @@
         </p:nvSpPr>
         <p:spPr>
           <a:xfrm>
-            <a:off x="1920240" y="3566160"/>
-            <a:ext cx="1097280" cy="914400"/>
+            <a:off x="1920240" y="3297549"/>
+            <a:ext cx="914400" cy="1142844"/>
           </a:xfrm>
           <a:prstGeom prst="rect">
             <a:avLst/>
@@ -24766,7 +24766,7 @@
         </p:nvSpPr>
         <p:spPr>
           <a:xfrm>
-            <a:off x="1920240" y="3566160"/>
+            <a:off x="1828800" y="3432122"/>
             <a:ext cx="1097280" cy="914400"/>
           </a:xfrm>
           <a:prstGeom prst="rect">
@@ -24805,8 +24805,8 @@
         </p:nvSpPr>
         <p:spPr>
           <a:xfrm>
-            <a:off x="2926080" y="2651760"/>
-            <a:ext cx="1188720" cy="1097280"/>
+            <a:off x="2821905" y="2651760"/>
+            <a:ext cx="1188720" cy="868680"/>
           </a:xfrm>
           <a:prstGeom prst="rect">
             <a:avLst/>
@@ -24837,8 +24837,8 @@
         </p:nvSpPr>
         <p:spPr>
           <a:xfrm>
-            <a:off x="2926080" y="2651760"/>
-            <a:ext cx="1188720" cy="1097280"/>
+            <a:off x="2821905" y="2651760"/>
+            <a:ext cx="1188720" cy="1009542"/>
           </a:xfrm>
           <a:prstGeom prst="rect">
             <a:avLst/>
@@ -24876,8 +24876,8 @@
         </p:nvSpPr>
         <p:spPr>
           <a:xfrm>
-            <a:off x="2743200" y="3749040"/>
-            <a:ext cx="1005840" cy="731520"/>
+            <a:off x="2844475" y="3529115"/>
+            <a:ext cx="1005840" cy="672152"/>
           </a:xfrm>
           <a:prstGeom prst="rect">
             <a:avLst/>
@@ -24908,7 +24908,7 @@
         </p:nvSpPr>
         <p:spPr>
           <a:xfrm>
-            <a:off x="2743200" y="3749040"/>
+            <a:off x="2821325" y="3529115"/>
             <a:ext cx="1005840" cy="731520"/>
           </a:xfrm>
           <a:prstGeom prst="rect">
@@ -24947,7 +24947,7 @@
         </p:nvSpPr>
         <p:spPr>
           <a:xfrm>
-            <a:off x="2743200" y="4480560"/>
+            <a:off x="2835800" y="4202760"/>
             <a:ext cx="822960" cy="457200"/>
           </a:xfrm>
           <a:prstGeom prst="rect">
@@ -24979,7 +24979,7 @@
         </p:nvSpPr>
         <p:spPr>
           <a:xfrm>
-            <a:off x="2743200" y="4480560"/>
+            <a:off x="2835800" y="4214335"/>
             <a:ext cx="822960" cy="457200"/>
           </a:xfrm>
           <a:prstGeom prst="rect">
@@ -25018,7 +25018,7 @@
         </p:nvSpPr>
         <p:spPr>
           <a:xfrm>
-            <a:off x="2651760" y="4526280"/>
+            <a:off x="3849735" y="4721729"/>
             <a:ext cx="640080" cy="320040"/>
           </a:xfrm>
           <a:prstGeom prst="rect">
@@ -25050,7 +25050,7 @@
         </p:nvSpPr>
         <p:spPr>
           <a:xfrm>
-            <a:off x="2651760" y="4526280"/>
+            <a:off x="3781155" y="4717198"/>
             <a:ext cx="640080" cy="320040"/>
           </a:xfrm>
           <a:prstGeom prst="rect">

</xml_diff>

<commit_message>
Update slide of day1
</commit_message>
<xml_diff>
--- a/day1/Day1_MiniZinc_Slides.pptx
+++ b/day1/Day1_MiniZinc_Slides.pptx
@@ -7870,7 +7870,62 @@
                 <a:ea typeface="Calibri" pitchFamily="34" charset="-122"/>
                 <a:cs typeface="Calibri" pitchFamily="34" charset="-120"/>
               </a:rPr>
-              <a:t>โจทย์: อบเค้กกล้วย (กำไร 40 บาท) และเค้กช็อก (กำไร 45 บาท) ให้ได้กำไรสูงสุด</a:t>
+              <a:t>โจทย์: อบเค้กกล้วย (</a:t>
+            </a:r>
+            <a:r>
+              <a:rPr lang="en-US" sz="1300" dirty="0" err="1">
+                <a:solidFill>
+                  <a:srgbClr val="FFFFFF"/>
+                </a:solidFill>
+                <a:latin typeface="Calibri" pitchFamily="34" charset="0"/>
+                <a:ea typeface="Calibri" pitchFamily="34" charset="-122"/>
+                <a:cs typeface="Calibri" pitchFamily="34" charset="-120"/>
+              </a:rPr>
+              <a:t>กำไร</a:t>
+            </a:r>
+            <a:r>
+              <a:rPr lang="en-US" sz="1300" dirty="0">
+                <a:solidFill>
+                  <a:srgbClr val="FFFFFF"/>
+                </a:solidFill>
+                <a:latin typeface="Calibri" pitchFamily="34" charset="0"/>
+                <a:ea typeface="Calibri" pitchFamily="34" charset="-122"/>
+                <a:cs typeface="Calibri" pitchFamily="34" charset="-120"/>
+              </a:rPr>
+              <a:t> 400 บาท) และเค้กช็อก (</a:t>
+            </a:r>
+            <a:r>
+              <a:rPr lang="en-US" sz="1300" dirty="0" err="1">
+                <a:solidFill>
+                  <a:srgbClr val="FFFFFF"/>
+                </a:solidFill>
+                <a:latin typeface="Calibri" pitchFamily="34" charset="0"/>
+                <a:ea typeface="Calibri" pitchFamily="34" charset="-122"/>
+                <a:cs typeface="Calibri" pitchFamily="34" charset="-120"/>
+              </a:rPr>
+              <a:t>กำไร</a:t>
+            </a:r>
+            <a:r>
+              <a:rPr lang="en-US" sz="1300">
+                <a:solidFill>
+                  <a:srgbClr val="FFFFFF"/>
+                </a:solidFill>
+                <a:latin typeface="Calibri" pitchFamily="34" charset="0"/>
+                <a:ea typeface="Calibri" pitchFamily="34" charset="-122"/>
+                <a:cs typeface="Calibri" pitchFamily="34" charset="-120"/>
+              </a:rPr>
+              <a:t> 450 </a:t>
+            </a:r>
+            <a:r>
+              <a:rPr lang="en-US" sz="1300" dirty="0">
+                <a:solidFill>
+                  <a:srgbClr val="FFFFFF"/>
+                </a:solidFill>
+                <a:latin typeface="Calibri" pitchFamily="34" charset="0"/>
+                <a:ea typeface="Calibri" pitchFamily="34" charset="-122"/>
+                <a:cs typeface="Calibri" pitchFamily="34" charset="-120"/>
+              </a:rPr>
+              <a:t>บาท) ให้ได้กำไรสูงสุด</a:t>
             </a:r>
             <a:endParaRPr lang="en-US" sz="1300" dirty="0"/>
           </a:p>

</xml_diff>

<commit_message>
Update starter files and slides for Day 1
</commit_message>
<xml_diff>
--- a/day1/Day1_MiniZinc_Slides.pptx
+++ b/day1/Day1_MiniZinc_Slides.pptx
@@ -6956,6 +6956,17 @@
               <a:buNone/>
             </a:pPr>
             <a:r>
+              <a:rPr lang="th-TH" sz="1100" dirty="0">
+                <a:solidFill>
+                  <a:srgbClr val="2D3748"/>
+                </a:solidFill>
+                <a:latin typeface="Calibri" pitchFamily="34" charset="0"/>
+                <a:ea typeface="Calibri" pitchFamily="34" charset="-122"/>
+                <a:cs typeface="Calibri" pitchFamily="34" charset="-120"/>
+              </a:rPr>
+              <a:t>เพิ่มตัวแปร</a:t>
+            </a:r>
+            <a:r>
               <a:rPr lang="en-US" sz="1100" dirty="0">
                 <a:solidFill>
                   <a:srgbClr val="2D3748"/>
@@ -6964,7 +6975,7 @@
                 <a:ea typeface="Calibri" pitchFamily="34" charset="-122"/>
                 <a:cs typeface="Calibri" pitchFamily="34" charset="-120"/>
               </a:rPr>
-              <a:t>Uncomment บรรทัด act → เพิ่ม constraint act != nsw; และ act != v; → รันและตรวจสอบ</a:t>
+              <a:t> act → เพิ่ม constraint act != nsw; และ act != v; → รันและตรวจสอบ</a:t>
             </a:r>
             <a:endParaRPr lang="en-US" sz="1100" dirty="0"/>
           </a:p>
@@ -17586,7 +17597,95 @@
                 <a:ea typeface="Calibri" pitchFamily="34" charset="-122"/>
                 <a:cs typeface="Calibri" pitchFamily="34" charset="-120"/>
               </a:rPr>
-              <a:t>constraint สำหรับแรงงาน (3*a + 5*b &lt;= 120) และวัตถุดิบ (5*a + 2*b &lt;= 150)</a:t>
+              <a:t>constraint </a:t>
+            </a:r>
+            <a:r>
+              <a:rPr lang="en-US" sz="1050" dirty="0" err="1">
+                <a:solidFill>
+                  <a:srgbClr val="2D3748"/>
+                </a:solidFill>
+                <a:latin typeface="Calibri" pitchFamily="34" charset="0"/>
+                <a:ea typeface="Calibri" pitchFamily="34" charset="-122"/>
+                <a:cs typeface="Calibri" pitchFamily="34" charset="-120"/>
+              </a:rPr>
+              <a:t>สำหรับแรงงาน</a:t>
+            </a:r>
+            <a:r>
+              <a:rPr lang="en-US" sz="1050" dirty="0">
+                <a:solidFill>
+                  <a:srgbClr val="2D3748"/>
+                </a:solidFill>
+                <a:latin typeface="Calibri" pitchFamily="34" charset="0"/>
+                <a:ea typeface="Calibri" pitchFamily="34" charset="-122"/>
+                <a:cs typeface="Calibri" pitchFamily="34" charset="-120"/>
+              </a:rPr>
+              <a:t> (</a:t>
+            </a:r>
+            <a:r>
+              <a:rPr lang="th-TH" sz="1050" dirty="0">
+                <a:solidFill>
+                  <a:srgbClr val="2D3748"/>
+                </a:solidFill>
+                <a:latin typeface="Calibri" pitchFamily="34" charset="0"/>
+                <a:ea typeface="Calibri" pitchFamily="34" charset="-122"/>
+                <a:cs typeface="Calibri" pitchFamily="34" charset="-120"/>
+              </a:rPr>
+              <a:t>แรงงานรวมต้องไม่เกิน </a:t>
+            </a:r>
+            <a:r>
+              <a:rPr lang="en-US" sz="1050" dirty="0">
+                <a:solidFill>
+                  <a:srgbClr val="2D3748"/>
+                </a:solidFill>
+                <a:latin typeface="Calibri" pitchFamily="34" charset="0"/>
+                <a:ea typeface="Calibri" pitchFamily="34" charset="-122"/>
+                <a:cs typeface="Calibri" pitchFamily="34" charset="-120"/>
+              </a:rPr>
+              <a:t>120) </a:t>
+            </a:r>
+            <a:r>
+              <a:rPr lang="en-US" sz="1050" dirty="0" err="1">
+                <a:solidFill>
+                  <a:srgbClr val="2D3748"/>
+                </a:solidFill>
+                <a:latin typeface="Calibri" pitchFamily="34" charset="0"/>
+                <a:ea typeface="Calibri" pitchFamily="34" charset="-122"/>
+                <a:cs typeface="Calibri" pitchFamily="34" charset="-120"/>
+              </a:rPr>
+              <a:t>และวัตถุดิบ</a:t>
+            </a:r>
+            <a:r>
+              <a:rPr lang="en-US" sz="1050" dirty="0">
+                <a:solidFill>
+                  <a:srgbClr val="2D3748"/>
+                </a:solidFill>
+                <a:latin typeface="Calibri" pitchFamily="34" charset="0"/>
+                <a:ea typeface="Calibri" pitchFamily="34" charset="-122"/>
+                <a:cs typeface="Calibri" pitchFamily="34" charset="-120"/>
+              </a:rPr>
+              <a:t> (</a:t>
+            </a:r>
+            <a:r>
+              <a:rPr lang="th-TH" sz="1050" dirty="0">
+                <a:solidFill>
+                  <a:srgbClr val="2D3748"/>
+                </a:solidFill>
+                <a:latin typeface="Calibri" pitchFamily="34" charset="0"/>
+                <a:ea typeface="Calibri" pitchFamily="34" charset="-122"/>
+                <a:cs typeface="Calibri" pitchFamily="34" charset="-120"/>
+              </a:rPr>
+              <a:t>วัตถุดิบรวมต้องไม่เกิน </a:t>
+            </a:r>
+            <a:r>
+              <a:rPr lang="en-US" sz="1050" dirty="0">
+                <a:solidFill>
+                  <a:srgbClr val="2D3748"/>
+                </a:solidFill>
+                <a:latin typeface="Calibri" pitchFamily="34" charset="0"/>
+                <a:ea typeface="Calibri" pitchFamily="34" charset="-122"/>
+                <a:cs typeface="Calibri" pitchFamily="34" charset="-120"/>
+              </a:rPr>
+              <a:t>150)</a:t>
             </a:r>
             <a:endParaRPr lang="en-US" sz="1050" dirty="0"/>
           </a:p>
@@ -17721,45 +17820,6 @@
               <a:t>กำหนด Objective: </a:t>
             </a:r>
             <a:endParaRPr lang="en-US" sz="1100" dirty="0"/>
-          </a:p>
-        </p:txBody>
-      </p:sp>
-      <p:sp>
-        <p:nvSpPr>
-          <p:cNvPr id="23" name="Text 21"/>
-          <p:cNvSpPr/>
-          <p:nvPr/>
-        </p:nvSpPr>
-        <p:spPr>
-          <a:xfrm>
-            <a:off x="3474720" y="3575304"/>
-            <a:ext cx="5166360" cy="347472"/>
-          </a:xfrm>
-          <a:prstGeom prst="rect">
-            <a:avLst/>
-          </a:prstGeom>
-          <a:noFill/>
-          <a:ln/>
-        </p:spPr>
-        <p:txBody>
-          <a:bodyPr wrap="square" rtlCol="0" anchor="ctr"/>
-          <a:lstStyle/>
-          <a:p>
-            <a:pPr marL="0" indent="0">
-              <a:buNone/>
-            </a:pPr>
-            <a:r>
-              <a:rPr lang="en-US" sz="1050" dirty="0">
-                <a:solidFill>
-                  <a:srgbClr val="2D3748"/>
-                </a:solidFill>
-                <a:latin typeface="Calibri" pitchFamily="34" charset="0"/>
-                <a:ea typeface="Calibri" pitchFamily="34" charset="-122"/>
-                <a:cs typeface="Calibri" pitchFamily="34" charset="-120"/>
-              </a:rPr>
-              <a:t>solve maximize 800*a + 1200*b; แล้วรันและตรวจสอบคำตอบ</a:t>
-            </a:r>
-            <a:endParaRPr lang="en-US" sz="1050" dirty="0"/>
           </a:p>
         </p:txBody>
       </p:sp>

</xml_diff>